<commit_message>
feat: add state-incentive and emergent-hub slides to FDI pitch deck
Two new slides (now 14 total, renumbered): "States are competing hard
on top of central incentives" (state top-ups per sector) and "Real
state hubs, with the evidence behind each one" (landed capital per
sector), condensed from the new state_central_incentives_and_emergent_hubs
bulletin. Includes the same two risk callouts as that bulletin (West
Bengal's 2025 incentive revocation, Hyderabad Pharma City's court
stay) rather than a sales-only slide.

PPTX and PDF rebuilt and verified via the same HTML-to-PNG-to-PPTX
pipeline, round-tripped through LibreOffice to confirm rendering.
</commit_message>
<xml_diff>
--- a/fdi_pitch/India_Trade_FDI_Pitch_Deck.pptx
+++ b/fdi_pitch/India_Trade_FDI_Pitch_Deck.pptx
@@ -17,6 +17,8 @@
     <p:sldId id="265" r:id="rId16"/>
     <p:sldId id="266" r:id="rId17"/>
     <p:sldId id="267" r:id="rId18"/>
+    <p:sldId id="268" r:id="rId19"/>
+    <p:sldId id="269" r:id="rId20"/>
   </p:sldIdLst>
   <p:sldSz cx="12192000" cy="6858000" type="screen4x3"/>
   <p:notesSz cx="6858000" cy="9144000"/>
@@ -3228,6 +3230,90 @@
       <p:pic>
         <p:nvPicPr>
           <p:cNvPr id="2" name="Picture 1" descr="slide_12.png"/>
+          <p:cNvPicPr>
+            <a:picLocks noChangeAspect="1"/>
+          </p:cNvPicPr>
+          <p:nvPr/>
+        </p:nvPicPr>
+        <p:blipFill>
+          <a:blip r:embed="rId2"/>
+          <a:stretch>
+            <a:fillRect/>
+          </a:stretch>
+        </p:blipFill>
+        <p:spPr>
+          <a:xfrm>
+            <a:off x="0" y="0"/>
+            <a:ext cx="12192000" cy="6858000"/>
+          </a:xfrm>
+          <a:prstGeom prst="rect">
+            <a:avLst/>
+          </a:prstGeom>
+        </p:spPr>
+      </p:pic>
+    </p:spTree>
+  </p:cSld>
+  <p:clrMapOvr>
+    <a:masterClrMapping/>
+  </p:clrMapOvr>
+</p:sld>
+</file>
+
+<file path=ppt/slides/slide13.xml><?xml version="1.0" encoding="utf-8"?>
+<p:sld xmlns:a="http://schemas.openxmlformats.org/drawingml/2006/main" xmlns:p="http://schemas.openxmlformats.org/presentationml/2006/main" xmlns:r="http://schemas.openxmlformats.org/officeDocument/2006/relationships">
+  <p:cSld>
+    <p:spTree>
+      <p:nvGrpSpPr>
+        <p:cNvPr id="1" name=""/>
+        <p:cNvGrpSpPr/>
+        <p:nvPr/>
+      </p:nvGrpSpPr>
+      <p:grpSpPr/>
+      <p:pic>
+        <p:nvPicPr>
+          <p:cNvPr id="2" name="Picture 1" descr="slide_13.png"/>
+          <p:cNvPicPr>
+            <a:picLocks noChangeAspect="1"/>
+          </p:cNvPicPr>
+          <p:nvPr/>
+        </p:nvPicPr>
+        <p:blipFill>
+          <a:blip r:embed="rId2"/>
+          <a:stretch>
+            <a:fillRect/>
+          </a:stretch>
+        </p:blipFill>
+        <p:spPr>
+          <a:xfrm>
+            <a:off x="0" y="0"/>
+            <a:ext cx="12192000" cy="6858000"/>
+          </a:xfrm>
+          <a:prstGeom prst="rect">
+            <a:avLst/>
+          </a:prstGeom>
+        </p:spPr>
+      </p:pic>
+    </p:spTree>
+  </p:cSld>
+  <p:clrMapOvr>
+    <a:masterClrMapping/>
+  </p:clrMapOvr>
+</p:sld>
+</file>
+
+<file path=ppt/slides/slide14.xml><?xml version="1.0" encoding="utf-8"?>
+<p:sld xmlns:a="http://schemas.openxmlformats.org/drawingml/2006/main" xmlns:p="http://schemas.openxmlformats.org/presentationml/2006/main" xmlns:r="http://schemas.openxmlformats.org/officeDocument/2006/relationships">
+  <p:cSld>
+    <p:spTree>
+      <p:nvGrpSpPr>
+        <p:cNvPr id="1" name=""/>
+        <p:cNvGrpSpPr/>
+        <p:nvPr/>
+      </p:nvGrpSpPr>
+      <p:grpSpPr/>
+      <p:pic>
+        <p:nvPicPr>
+          <p:cNvPr id="2" name="Picture 1" descr="slide_14.png"/>
           <p:cNvPicPr>
             <a:picLocks noChangeAspect="1"/>
           </p:cNvPicPr>

</xml_diff>

<commit_message>
Extend FDI pitch deck to 18 slides: Medical Devices, country-strategy matrix, game theory, tariff timeline
Adds Medical Devices as a sixth PLI-backed sector, a full 10-sector
country-strategy matrix (including Textiles & Apparel's honest
no-country-found finding), a Generalized Nash Equilibrium tariff-rate-quota
slide applied to India's May-2026 AC-compressor import quota, and the
official 2025-2026 tariff timeline. Title/CTA copy updated from "five
sectors" to "ten sectors" throughout. PPTX/PDF rebuilt via the established
headless-Chrome screenshot -> python-pptx -> soffice pipeline.
</commit_message>
<xml_diff>
--- a/fdi_pitch/India_Trade_FDI_Pitch_Deck.pptx
+++ b/fdi_pitch/India_Trade_FDI_Pitch_Deck.pptx
@@ -19,6 +19,10 @@
     <p:sldId id="267" r:id="rId18"/>
     <p:sldId id="268" r:id="rId19"/>
     <p:sldId id="269" r:id="rId20"/>
+    <p:sldId id="270" r:id="rId21"/>
+    <p:sldId id="271" r:id="rId22"/>
+    <p:sldId id="272" r:id="rId23"/>
+    <p:sldId id="273" r:id="rId24"/>
   </p:sldIdLst>
   <p:sldSz cx="12192000" cy="6858000" type="screen4x3"/>
   <p:notesSz cx="6858000" cy="9144000"/>
@@ -3314,6 +3318,174 @@
       <p:pic>
         <p:nvPicPr>
           <p:cNvPr id="2" name="Picture 1" descr="slide_14.png"/>
+          <p:cNvPicPr>
+            <a:picLocks noChangeAspect="1"/>
+          </p:cNvPicPr>
+          <p:nvPr/>
+        </p:nvPicPr>
+        <p:blipFill>
+          <a:blip r:embed="rId2"/>
+          <a:stretch>
+            <a:fillRect/>
+          </a:stretch>
+        </p:blipFill>
+        <p:spPr>
+          <a:xfrm>
+            <a:off x="0" y="0"/>
+            <a:ext cx="12192000" cy="6858000"/>
+          </a:xfrm>
+          <a:prstGeom prst="rect">
+            <a:avLst/>
+          </a:prstGeom>
+        </p:spPr>
+      </p:pic>
+    </p:spTree>
+  </p:cSld>
+  <p:clrMapOvr>
+    <a:masterClrMapping/>
+  </p:clrMapOvr>
+</p:sld>
+</file>
+
+<file path=ppt/slides/slide15.xml><?xml version="1.0" encoding="utf-8"?>
+<p:sld xmlns:a="http://schemas.openxmlformats.org/drawingml/2006/main" xmlns:p="http://schemas.openxmlformats.org/presentationml/2006/main" xmlns:r="http://schemas.openxmlformats.org/officeDocument/2006/relationships">
+  <p:cSld>
+    <p:spTree>
+      <p:nvGrpSpPr>
+        <p:cNvPr id="1" name=""/>
+        <p:cNvGrpSpPr/>
+        <p:nvPr/>
+      </p:nvGrpSpPr>
+      <p:grpSpPr/>
+      <p:pic>
+        <p:nvPicPr>
+          <p:cNvPr id="2" name="Picture 1" descr="slide_15.png"/>
+          <p:cNvPicPr>
+            <a:picLocks noChangeAspect="1"/>
+          </p:cNvPicPr>
+          <p:nvPr/>
+        </p:nvPicPr>
+        <p:blipFill>
+          <a:blip r:embed="rId2"/>
+          <a:stretch>
+            <a:fillRect/>
+          </a:stretch>
+        </p:blipFill>
+        <p:spPr>
+          <a:xfrm>
+            <a:off x="0" y="0"/>
+            <a:ext cx="12192000" cy="6858000"/>
+          </a:xfrm>
+          <a:prstGeom prst="rect">
+            <a:avLst/>
+          </a:prstGeom>
+        </p:spPr>
+      </p:pic>
+    </p:spTree>
+  </p:cSld>
+  <p:clrMapOvr>
+    <a:masterClrMapping/>
+  </p:clrMapOvr>
+</p:sld>
+</file>
+
+<file path=ppt/slides/slide16.xml><?xml version="1.0" encoding="utf-8"?>
+<p:sld xmlns:a="http://schemas.openxmlformats.org/drawingml/2006/main" xmlns:p="http://schemas.openxmlformats.org/presentationml/2006/main" xmlns:r="http://schemas.openxmlformats.org/officeDocument/2006/relationships">
+  <p:cSld>
+    <p:spTree>
+      <p:nvGrpSpPr>
+        <p:cNvPr id="1" name=""/>
+        <p:cNvGrpSpPr/>
+        <p:nvPr/>
+      </p:nvGrpSpPr>
+      <p:grpSpPr/>
+      <p:pic>
+        <p:nvPicPr>
+          <p:cNvPr id="2" name="Picture 1" descr="slide_16.png"/>
+          <p:cNvPicPr>
+            <a:picLocks noChangeAspect="1"/>
+          </p:cNvPicPr>
+          <p:nvPr/>
+        </p:nvPicPr>
+        <p:blipFill>
+          <a:blip r:embed="rId2"/>
+          <a:stretch>
+            <a:fillRect/>
+          </a:stretch>
+        </p:blipFill>
+        <p:spPr>
+          <a:xfrm>
+            <a:off x="0" y="0"/>
+            <a:ext cx="12192000" cy="6858000"/>
+          </a:xfrm>
+          <a:prstGeom prst="rect">
+            <a:avLst/>
+          </a:prstGeom>
+        </p:spPr>
+      </p:pic>
+    </p:spTree>
+  </p:cSld>
+  <p:clrMapOvr>
+    <a:masterClrMapping/>
+  </p:clrMapOvr>
+</p:sld>
+</file>
+
+<file path=ppt/slides/slide17.xml><?xml version="1.0" encoding="utf-8"?>
+<p:sld xmlns:a="http://schemas.openxmlformats.org/drawingml/2006/main" xmlns:p="http://schemas.openxmlformats.org/presentationml/2006/main" xmlns:r="http://schemas.openxmlformats.org/officeDocument/2006/relationships">
+  <p:cSld>
+    <p:spTree>
+      <p:nvGrpSpPr>
+        <p:cNvPr id="1" name=""/>
+        <p:cNvGrpSpPr/>
+        <p:nvPr/>
+      </p:nvGrpSpPr>
+      <p:grpSpPr/>
+      <p:pic>
+        <p:nvPicPr>
+          <p:cNvPr id="2" name="Picture 1" descr="slide_17.png"/>
+          <p:cNvPicPr>
+            <a:picLocks noChangeAspect="1"/>
+          </p:cNvPicPr>
+          <p:nvPr/>
+        </p:nvPicPr>
+        <p:blipFill>
+          <a:blip r:embed="rId2"/>
+          <a:stretch>
+            <a:fillRect/>
+          </a:stretch>
+        </p:blipFill>
+        <p:spPr>
+          <a:xfrm>
+            <a:off x="0" y="0"/>
+            <a:ext cx="12192000" cy="6858000"/>
+          </a:xfrm>
+          <a:prstGeom prst="rect">
+            <a:avLst/>
+          </a:prstGeom>
+        </p:spPr>
+      </p:pic>
+    </p:spTree>
+  </p:cSld>
+  <p:clrMapOvr>
+    <a:masterClrMapping/>
+  </p:clrMapOvr>
+</p:sld>
+</file>
+
+<file path=ppt/slides/slide18.xml><?xml version="1.0" encoding="utf-8"?>
+<p:sld xmlns:a="http://schemas.openxmlformats.org/drawingml/2006/main" xmlns:p="http://schemas.openxmlformats.org/presentationml/2006/main" xmlns:r="http://schemas.openxmlformats.org/officeDocument/2006/relationships">
+  <p:cSld>
+    <p:spTree>
+      <p:nvGrpSpPr>
+        <p:cNvPr id="1" name=""/>
+        <p:cNvGrpSpPr/>
+        <p:nvPr/>
+      </p:nvGrpSpPr>
+      <p:grpSpPr/>
+      <p:pic>
+        <p:nvPicPr>
+          <p:cNvPr id="2" name="Picture 1" descr="slide_18.png"/>
           <p:cNvPicPr>
             <a:picLocks noChangeAspect="1"/>
           </p:cNvPicPr>

</xml_diff>

<commit_message>
Add master-scorecard traffic-light slide to FDI pitch deck (18->19 slides)
New slide 18 condenses the master sector scorecard into a 10-tile
traffic-light grid (teal/gold/alert, matching the deck's existing palette)
showing whether real FDI-equity actually followed each PLI scheme's launch
-- 2 green, 5 amber, 3 red -- plus the registered-office data-quality
finding as a methodology callout. All page numbers renumbered 01/19-19/19;
PPTX/PDF rebuilt via the established headless-Chrome -> pptx -> soffice
pipeline and verified at 19 pages.
</commit_message>
<xml_diff>
--- a/fdi_pitch/India_Trade_FDI_Pitch_Deck.pptx
+++ b/fdi_pitch/India_Trade_FDI_Pitch_Deck.pptx
@@ -23,6 +23,7 @@
     <p:sldId id="271" r:id="rId22"/>
     <p:sldId id="272" r:id="rId23"/>
     <p:sldId id="273" r:id="rId24"/>
+    <p:sldId id="274" r:id="rId25"/>
   </p:sldIdLst>
   <p:sldSz cx="12192000" cy="6858000" type="screen4x3"/>
   <p:notesSz cx="6858000" cy="9144000"/>
@@ -3515,6 +3516,48 @@
 </p:sld>
 </file>
 
+<file path=ppt/slides/slide19.xml><?xml version="1.0" encoding="utf-8"?>
+<p:sld xmlns:a="http://schemas.openxmlformats.org/drawingml/2006/main" xmlns:p="http://schemas.openxmlformats.org/presentationml/2006/main" xmlns:r="http://schemas.openxmlformats.org/officeDocument/2006/relationships">
+  <p:cSld>
+    <p:spTree>
+      <p:nvGrpSpPr>
+        <p:cNvPr id="1" name=""/>
+        <p:cNvGrpSpPr/>
+        <p:nvPr/>
+      </p:nvGrpSpPr>
+      <p:grpSpPr/>
+      <p:pic>
+        <p:nvPicPr>
+          <p:cNvPr id="2" name="Picture 1" descr="slide_19.png"/>
+          <p:cNvPicPr>
+            <a:picLocks noChangeAspect="1"/>
+          </p:cNvPicPr>
+          <p:nvPr/>
+        </p:nvPicPr>
+        <p:blipFill>
+          <a:blip r:embed="rId2"/>
+          <a:stretch>
+            <a:fillRect/>
+          </a:stretch>
+        </p:blipFill>
+        <p:spPr>
+          <a:xfrm>
+            <a:off x="0" y="0"/>
+            <a:ext cx="12192000" cy="6858000"/>
+          </a:xfrm>
+          <a:prstGeom prst="rect">
+            <a:avLst/>
+          </a:prstGeom>
+        </p:spPr>
+      </p:pic>
+    </p:spTree>
+  </p:cSld>
+  <p:clrMapOvr>
+    <a:masterClrMapping/>
+  </p:clrMapOvr>
+</p:sld>
+</file>
+
 <file path=ppt/slides/slide2.xml><?xml version="1.0" encoding="utf-8"?>
 <p:sld xmlns:a="http://schemas.openxmlformats.org/drawingml/2006/main" xmlns:p="http://schemas.openxmlformats.org/presentationml/2006/main" xmlns:r="http://schemas.openxmlformats.org/officeDocument/2006/relationships">
   <p:cSld>

</xml_diff>

<commit_message>
Add domestic-capital-vs-FDI rate slide to FDI pitch deck (19->20 slides)
New slide 19 condenses the domestic-vs-FDI capital case into the deck's
existing visual system: India's two-tier cost of capital (RBI repo,
AAA bonds, EBLR-priced loans) alongside the 9 target countries' policy
rates, plus the domestic-capital-states vs. FDI-states pattern and the
honest ICRA cross-check caveat. Page numbers renumbered 01/20-19/20;
PPTX/PDF rebuilt and verified at 20 pages.
</commit_message>
<xml_diff>
--- a/fdi_pitch/India_Trade_FDI_Pitch_Deck.pptx
+++ b/fdi_pitch/India_Trade_FDI_Pitch_Deck.pptx
@@ -24,6 +24,7 @@
     <p:sldId id="272" r:id="rId23"/>
     <p:sldId id="273" r:id="rId24"/>
     <p:sldId id="274" r:id="rId25"/>
+    <p:sldId id="275" r:id="rId26"/>
   </p:sldIdLst>
   <p:sldSz cx="12192000" cy="6858000" type="screen4x3"/>
   <p:notesSz cx="6858000" cy="9144000"/>
@@ -3600,6 +3601,48 @@
 </p:sld>
 </file>
 
+<file path=ppt/slides/slide20.xml><?xml version="1.0" encoding="utf-8"?>
+<p:sld xmlns:a="http://schemas.openxmlformats.org/drawingml/2006/main" xmlns:p="http://schemas.openxmlformats.org/presentationml/2006/main" xmlns:r="http://schemas.openxmlformats.org/officeDocument/2006/relationships">
+  <p:cSld>
+    <p:spTree>
+      <p:nvGrpSpPr>
+        <p:cNvPr id="1" name=""/>
+        <p:cNvGrpSpPr/>
+        <p:nvPr/>
+      </p:nvGrpSpPr>
+      <p:grpSpPr/>
+      <p:pic>
+        <p:nvPicPr>
+          <p:cNvPr id="2" name="Picture 1" descr="slide_20.png"/>
+          <p:cNvPicPr>
+            <a:picLocks noChangeAspect="1"/>
+          </p:cNvPicPr>
+          <p:nvPr/>
+        </p:nvPicPr>
+        <p:blipFill>
+          <a:blip r:embed="rId2"/>
+          <a:stretch>
+            <a:fillRect/>
+          </a:stretch>
+        </p:blipFill>
+        <p:spPr>
+          <a:xfrm>
+            <a:off x="0" y="0"/>
+            <a:ext cx="12192000" cy="6858000"/>
+          </a:xfrm>
+          <a:prstGeom prst="rect">
+            <a:avLst/>
+          </a:prstGeom>
+        </p:spPr>
+      </p:pic>
+    </p:spTree>
+  </p:cSld>
+  <p:clrMapOvr>
+    <a:masterClrMapping/>
+  </p:clrMapOvr>
+</p:sld>
+</file>
+
 <file path=ppt/slides/slide3.xml><?xml version="1.0" encoding="utf-8"?>
 <p:sld xmlns:a="http://schemas.openxmlformats.org/drawingml/2006/main" xmlns:p="http://schemas.openxmlformats.org/presentationml/2006/main" xmlns:r="http://schemas.openxmlformats.org/officeDocument/2006/relationships">
   <p:cSld>

</xml_diff>

<commit_message>
Add FY2025-26 verdict re-run slide to FDI pitch deck (20 -> 21 slides)
New slide 20, 'Re-run on FY2025-26 data: the verdicts moved' -- the three
verdict movers (Electronics -43.5% and Medical Devices -40.4%, both
green->amber; Pharma +114%, amber->green), the export-half-working /
import-half-not-yet split, and a link to the interactive dashboard.
Framed as a credibility feature: the analysis refreshes when the data
does. All page numbers renumbered to /21; PPTX and PDF rebuilt and
verified at 21 pages; README and manifest slide counts updated.
</commit_message>
<xml_diff>
--- a/fdi_pitch/India_Trade_FDI_Pitch_Deck.pptx
+++ b/fdi_pitch/India_Trade_FDI_Pitch_Deck.pptx
@@ -25,6 +25,7 @@
     <p:sldId id="273" r:id="rId24"/>
     <p:sldId id="274" r:id="rId25"/>
     <p:sldId id="275" r:id="rId26"/>
+    <p:sldId id="276" r:id="rId27"/>
   </p:sldIdLst>
   <p:sldSz cx="12192000" cy="6858000" type="screen4x3"/>
   <p:notesSz cx="6858000" cy="9144000"/>
@@ -3643,6 +3644,48 @@
 </p:sld>
 </file>
 
+<file path=ppt/slides/slide21.xml><?xml version="1.0" encoding="utf-8"?>
+<p:sld xmlns:a="http://schemas.openxmlformats.org/drawingml/2006/main" xmlns:p="http://schemas.openxmlformats.org/presentationml/2006/main" xmlns:r="http://schemas.openxmlformats.org/officeDocument/2006/relationships">
+  <p:cSld>
+    <p:spTree>
+      <p:nvGrpSpPr>
+        <p:cNvPr id="1" name=""/>
+        <p:cNvGrpSpPr/>
+        <p:nvPr/>
+      </p:nvGrpSpPr>
+      <p:grpSpPr/>
+      <p:pic>
+        <p:nvPicPr>
+          <p:cNvPr id="2" name="Picture 1" descr="slide_21.png"/>
+          <p:cNvPicPr>
+            <a:picLocks noChangeAspect="1"/>
+          </p:cNvPicPr>
+          <p:nvPr/>
+        </p:nvPicPr>
+        <p:blipFill>
+          <a:blip r:embed="rId2"/>
+          <a:stretch>
+            <a:fillRect/>
+          </a:stretch>
+        </p:blipFill>
+        <p:spPr>
+          <a:xfrm>
+            <a:off x="0" y="0"/>
+            <a:ext cx="12192000" cy="6858000"/>
+          </a:xfrm>
+          <a:prstGeom prst="rect">
+            <a:avLst/>
+          </a:prstGeom>
+        </p:spPr>
+      </p:pic>
+    </p:spTree>
+  </p:cSld>
+  <p:clrMapOvr>
+    <a:masterClrMapping/>
+  </p:clrMapOvr>
+</p:sld>
+</file>
+
 <file path=ppt/slides/slide3.xml><?xml version="1.0" encoding="utf-8"?>
 <p:sld xmlns:a="http://schemas.openxmlformats.org/drawingml/2006/main" xmlns:p="http://schemas.openxmlformats.org/presentationml/2006/main" xmlns:r="http://schemas.openxmlformats.org/officeDocument/2006/relationships">
   <p:cSld>

</xml_diff>

<commit_message>
Add PLI report card slide to FDI pitch deck (21 -> 22 slides)
New slide 21, 'Does the incentive actually get paid? Grades, A to F' --
the five grade buckets as color-coded columns (Pharma/Electronics/Bulk
Drugs at A; ACC Battery alone at F with zero disbursed), the
Rs 28,748cr / ~15%-of-outlay headline, the PIB-credited producing
companies band (Micron/Kaynes/CG Semi, Foxconn/Dixon, 27 bulk-drug
plants), and the transparency tell that underperforming schemes are the
anonymous ones. Framed for investors: the grade is the probability the
scheme's money actually arrives. Page numbers renumbered to /22;
PPTX/PDF rebuilt and verified at 22 pages.
</commit_message>
<xml_diff>
--- a/fdi_pitch/India_Trade_FDI_Pitch_Deck.pptx
+++ b/fdi_pitch/India_Trade_FDI_Pitch_Deck.pptx
@@ -26,6 +26,7 @@
     <p:sldId id="274" r:id="rId25"/>
     <p:sldId id="275" r:id="rId26"/>
     <p:sldId id="276" r:id="rId27"/>
+    <p:sldId id="277" r:id="rId28"/>
   </p:sldIdLst>
   <p:sldSz cx="12192000" cy="6858000" type="screen4x3"/>
   <p:notesSz cx="6858000" cy="9144000"/>
@@ -3657,6 +3658,48 @@
       <p:pic>
         <p:nvPicPr>
           <p:cNvPr id="2" name="Picture 1" descr="slide_21.png"/>
+          <p:cNvPicPr>
+            <a:picLocks noChangeAspect="1"/>
+          </p:cNvPicPr>
+          <p:nvPr/>
+        </p:nvPicPr>
+        <p:blipFill>
+          <a:blip r:embed="rId2"/>
+          <a:stretch>
+            <a:fillRect/>
+          </a:stretch>
+        </p:blipFill>
+        <p:spPr>
+          <a:xfrm>
+            <a:off x="0" y="0"/>
+            <a:ext cx="12192000" cy="6858000"/>
+          </a:xfrm>
+          <a:prstGeom prst="rect">
+            <a:avLst/>
+          </a:prstGeom>
+        </p:spPr>
+      </p:pic>
+    </p:spTree>
+  </p:cSld>
+  <p:clrMapOvr>
+    <a:masterClrMapping/>
+  </p:clrMapOvr>
+</p:sld>
+</file>
+
+<file path=ppt/slides/slide22.xml><?xml version="1.0" encoding="utf-8"?>
+<p:sld xmlns:a="http://schemas.openxmlformats.org/drawingml/2006/main" xmlns:p="http://schemas.openxmlformats.org/presentationml/2006/main" xmlns:r="http://schemas.openxmlformats.org/officeDocument/2006/relationships">
+  <p:cSld>
+    <p:spTree>
+      <p:nvGrpSpPr>
+        <p:cNvPr id="1" name=""/>
+        <p:cNvGrpSpPr/>
+        <p:nvPr/>
+      </p:nvGrpSpPr>
+      <p:grpSpPr/>
+      <p:pic>
+        <p:nvPicPr>
+          <p:cNvPr id="2" name="Picture 1" descr="slide_22.png"/>
           <p:cNvPicPr>
             <a:picLocks noChangeAspect="1"/>
           </p:cNvPicPr>

</xml_diff>

<commit_message>
Add EC clearance-pipeline slide to FDI pitch deck (22 -> 23 slides)
New slide 22, 'What's actually coming: the environmental-clearance
register' -- paired granted/ToR bars for the top pipeline states
(Gujarat 1,049+836, Maharashtra 390+519 with ToR exceeding grants,
Odisha, Karnataka), the flagship clearance-status list (Micron/Kaynes/
Reliance-electrolyser granted; Dholera fab, Assam ATMP and Agratas in
EIA; all 3 Bulk Drug Parks and 3 PM MITRA parks cleared), and the
absences-are-due-diligence callout (POSCO-JSW JV: no EC application;
RRPCL: absent entirely). Investor framing: the openly-queryable
register is a free diligence tool -- any Indian project's clearance
reality is one API call away. Page numbers renumbered to /23; PPTX/PDF
rebuilt and verified at 23 pages.
</commit_message>
<xml_diff>
--- a/fdi_pitch/India_Trade_FDI_Pitch_Deck.pptx
+++ b/fdi_pitch/India_Trade_FDI_Pitch_Deck.pptx
@@ -27,6 +27,7 @@
     <p:sldId id="275" r:id="rId26"/>
     <p:sldId id="276" r:id="rId27"/>
     <p:sldId id="277" r:id="rId28"/>
+    <p:sldId id="278" r:id="rId29"/>
   </p:sldIdLst>
   <p:sldSz cx="12192000" cy="6858000" type="screen4x3"/>
   <p:notesSz cx="6858000" cy="9144000"/>
@@ -3700,6 +3701,48 @@
       <p:pic>
         <p:nvPicPr>
           <p:cNvPr id="2" name="Picture 1" descr="slide_22.png"/>
+          <p:cNvPicPr>
+            <a:picLocks noChangeAspect="1"/>
+          </p:cNvPicPr>
+          <p:nvPr/>
+        </p:nvPicPr>
+        <p:blipFill>
+          <a:blip r:embed="rId2"/>
+          <a:stretch>
+            <a:fillRect/>
+          </a:stretch>
+        </p:blipFill>
+        <p:spPr>
+          <a:xfrm>
+            <a:off x="0" y="0"/>
+            <a:ext cx="12192000" cy="6858000"/>
+          </a:xfrm>
+          <a:prstGeom prst="rect">
+            <a:avLst/>
+          </a:prstGeom>
+        </p:spPr>
+      </p:pic>
+    </p:spTree>
+  </p:cSld>
+  <p:clrMapOvr>
+    <a:masterClrMapping/>
+  </p:clrMapOvr>
+</p:sld>
+</file>
+
+<file path=ppt/slides/slide23.xml><?xml version="1.0" encoding="utf-8"?>
+<p:sld xmlns:a="http://schemas.openxmlformats.org/drawingml/2006/main" xmlns:p="http://schemas.openxmlformats.org/presentationml/2006/main" xmlns:r="http://schemas.openxmlformats.org/officeDocument/2006/relationships">
+  <p:cSld>
+    <p:spTree>
+      <p:nvGrpSpPr>
+        <p:cNvPr id="1" name=""/>
+        <p:cNvGrpSpPr/>
+        <p:nvPr/>
+      </p:nvGrpSpPr>
+      <p:grpSpPr/>
+      <p:pic>
+        <p:nvPicPr>
+          <p:cNvPr id="2" name="Picture 1" descr="slide_23.png"/>
           <p:cNvPicPr>
             <a:picLocks noChangeAspect="1"/>
           </p:cNvPicPr>

</xml_diff>